<commit_message>
Update digital poster PowerPoint template
Replace Diplomarbeit/doc/HTL-DA_Digitale_PosterVorlage_Infoterminal2.pptx with an updated binary PowerPoint file. The poster template content/layout/styles were modified; changes are binary so no textual diff is available.
</commit_message>
<xml_diff>
--- a/Diplomarbeit/doc/HTL-DA_Digitale_PosterVorlage_Infoterminal2.pptx
+++ b/Diplomarbeit/doc/HTL-DA_Digitale_PosterVorlage_Infoterminal2.pptx
@@ -2,16 +2,16 @@
 <file path=ppt/presentation.xml><?xml version="1.0" encoding="utf-8"?>
 <p:presentation xmlns:a="http://schemas.openxmlformats.org/drawingml/2006/main" xmlns:r="http://schemas.openxmlformats.org/officeDocument/2006/relationships" xmlns:p="http://schemas.openxmlformats.org/presentationml/2006/main" saveSubsetFonts="1">
   <p:sldMasterIdLst>
-    <p:sldMasterId id="2147483660" r:id="rId1"/>
+    <p:sldMasterId id="2147483660" r:id="rId4"/>
   </p:sldMasterIdLst>
   <p:notesMasterIdLst>
-    <p:notesMasterId r:id="rId3"/>
+    <p:notesMasterId r:id="rId6"/>
   </p:notesMasterIdLst>
   <p:handoutMasterIdLst>
-    <p:handoutMasterId r:id="rId4"/>
+    <p:handoutMasterId r:id="rId7"/>
   </p:handoutMasterIdLst>
   <p:sldIdLst>
-    <p:sldId id="259" r:id="rId2"/>
+    <p:sldId id="259" r:id="rId5"/>
   </p:sldIdLst>
   <p:sldSz cx="30275213" cy="42803763"/>
   <p:notesSz cx="6858000" cy="9144000"/>
@@ -226,7 +226,7 @@
           <a:p>
             <a:fld id="{47747906-58F8-41D5-91B4-3B180173CB0D}" type="datetimeFigureOut">
               <a:rPr lang="de-DE" smtClean="0"/>
-              <a:t>04.04.2025</a:t>
+              <a:t>27.02.2026</a:t>
             </a:fld>
             <a:endParaRPr lang="de-DE"/>
           </a:p>
@@ -403,7 +403,7 @@
           <a:p>
             <a:fld id="{B4145E3C-60A8-4CC3-BBE9-1D0B1ECC86AD}" type="datetimeFigureOut">
               <a:rPr lang="de-DE" smtClean="0"/>
-              <a:t>04.04.2025</a:t>
+              <a:t>27.02.2026</a:t>
             </a:fld>
             <a:endParaRPr lang="de-DE"/>
           </a:p>
@@ -2069,42 +2069,6 @@
       </p:grpSpPr>
       <p:sp>
         <p:nvSpPr>
-          <p:cNvPr id="2" name="Bildplatzhalter 1">
-            <a:extLst>
-              <a:ext uri="{FF2B5EF4-FFF2-40B4-BE49-F238E27FC236}">
-                <a16:creationId xmlns:a16="http://schemas.microsoft.com/office/drawing/2014/main" id="{B8BAC069-0ADE-4BF8-89E6-B43EBAE6E3FB}"/>
-              </a:ext>
-            </a:extLst>
-          </p:cNvPr>
-          <p:cNvSpPr>
-            <a:spLocks noGrp="1"/>
-          </p:cNvSpPr>
-          <p:nvPr>
-            <p:ph type="pic" sz="quarter" idx="10"/>
-          </p:nvPr>
-        </p:nvSpPr>
-        <p:spPr/>
-      </p:sp>
-      <p:sp>
-        <p:nvSpPr>
-          <p:cNvPr id="10" name="Bildplatzhalter 9">
-            <a:extLst>
-              <a:ext uri="{FF2B5EF4-FFF2-40B4-BE49-F238E27FC236}">
-                <a16:creationId xmlns:a16="http://schemas.microsoft.com/office/drawing/2014/main" id="{34EA29B8-90F0-481F-8CF5-29471DBFA7CD}"/>
-              </a:ext>
-            </a:extLst>
-          </p:cNvPr>
-          <p:cNvSpPr>
-            <a:spLocks noGrp="1"/>
-          </p:cNvSpPr>
-          <p:nvPr>
-            <p:ph type="pic" sz="quarter" idx="11"/>
-          </p:nvPr>
-        </p:nvSpPr>
-        <p:spPr/>
-      </p:sp>
-      <p:sp>
-        <p:nvSpPr>
           <p:cNvPr id="11" name="Inhaltsplatzhalter 10">
             <a:extLst>
               <a:ext uri="{FF2B5EF4-FFF2-40B4-BE49-F238E27FC236}">
@@ -2124,7 +2088,16 @@
           <a:bodyPr/>
           <a:lstStyle/>
           <a:p>
-            <a:endParaRPr lang="de-AT"/>
+            <a:pPr algn="l"/>
+            <a:endParaRPr lang="de-DE" b="0" dirty="0"/>
+          </a:p>
+          <a:p>
+            <a:pPr algn="l"/>
+            <a:r>
+              <a:rPr lang="de-DE" b="0" dirty="0"/>
+              <a:t>Ziel der Diplomarbeit ist eine sichere digitale Übungsumgebung für den Unterricht. Alle Schülerinnen und Schüler sollen unter denselben technischen Bedingungen arbeiten können – unabhängig von der Leistung des eigenen Laptops. In dieser Umgebung können Cyberangriffe realitätsnah, aber gefahrlos geübt werden. Gleichzeitig soll sichtbar werden, wie Angriffe früh erkannt und nachvollziehbar dargestellt werden können.</a:t>
+            </a:r>
+            <a:endParaRPr lang="de-AT" dirty="0"/>
           </a:p>
         </p:txBody>
       </p:sp>
@@ -2144,12 +2117,30 @@
             <p:ph type="body" sz="quarter" idx="14"/>
           </p:nvPr>
         </p:nvSpPr>
-        <p:spPr/>
+        <p:spPr>
+          <a:xfrm>
+            <a:off x="1371600" y="29290557"/>
+            <a:ext cx="13766006" cy="7945485"/>
+          </a:xfrm>
+        </p:spPr>
         <p:txBody>
           <a:bodyPr/>
           <a:lstStyle/>
           <a:p>
-            <a:endParaRPr lang="de-AT"/>
+            <a:pPr algn="l"/>
+            <a:r>
+              <a:rPr lang="de-DE" b="0" dirty="0"/>
+              <a:t>Im praktischen Teil wurde eine vollständige virtuelle Übungsumgebung aufgebaut und erfolgreich getestet. Typische Angriffsszenarien konnten realitätsnah simuliert werden, ohne produktive Systeme zu gefährden. Das eingesetzte Überwachungssystem erkannte verdächtige Aktivitäten und stellte sie zentral und verständlich dar. Dadurch konnte der Ablauf eines Angriffs Schritt für Schritt nachvollzogen werden. Insgesamt zeigt das Ergebnis, dass die Lösung für praxisnahen, fairen und modernen </a:t>
+            </a:r>
+            <a:r>
+              <a:rPr lang="de-DE" b="0" dirty="0" err="1"/>
+              <a:t>Cybersecurity</a:t>
+            </a:r>
+            <a:r>
+              <a:rPr lang="de-DE" b="0" dirty="0"/>
+              <a:t>-Unterricht sehr gut geeignet ist.</a:t>
+            </a:r>
+            <a:endParaRPr lang="de-AT" dirty="0"/>
           </a:p>
         </p:txBody>
       </p:sp>
@@ -2174,7 +2165,15 @@
           <a:bodyPr/>
           <a:lstStyle/>
           <a:p>
-            <a:endParaRPr lang="de-AT"/>
+            <a:r>
+              <a:rPr lang="de-AT" dirty="0"/>
+              <a:t>Tobias Eichelberger, Lukas </a:t>
+            </a:r>
+            <a:r>
+              <a:rPr lang="de-AT" dirty="0" err="1"/>
+              <a:t>Macuha</a:t>
+            </a:r>
+            <a:endParaRPr lang="de-AT" dirty="0"/>
           </a:p>
         </p:txBody>
       </p:sp>
@@ -2194,12 +2193,22 @@
             <p:ph type="body" sz="quarter" idx="16"/>
           </p:nvPr>
         </p:nvSpPr>
-        <p:spPr/>
+        <p:spPr>
+          <a:xfrm>
+            <a:off x="15971520" y="18521319"/>
+            <a:ext cx="13350240" cy="7945485"/>
+          </a:xfrm>
+        </p:spPr>
         <p:txBody>
           <a:bodyPr/>
           <a:lstStyle/>
           <a:p>
-            <a:endParaRPr lang="de-AT"/>
+            <a:pPr algn="l"/>
+            <a:r>
+              <a:rPr lang="de-DE" b="0" dirty="0"/>
+              <a:t>Im theoretischen Teil wurde untersucht, wie Angriffe in Computernetzwerken entstehen, welche typischen Angriffsschritte vorkommen und welche Schutzmaßnahmen besonders wirksam sind. Zusätzlich wurden verschiedene Überwachungslösungen zur Angriffserkennung verglichen. Die wichtigste Erkenntnis: Nicht einzelne Tools, sondern das Zusammenspiel aus klaren Sicherheitsregeln, starken Passwörtern, sinnvoll vergebenen Berechtigungen und laufender Überwachung schützt ein Netzwerk nachhaltig. So können viele Sicherheitsvorfälle früh erkannt und begrenzt werden.</a:t>
+            </a:r>
+            <a:endParaRPr lang="de-AT" dirty="0"/>
           </a:p>
         </p:txBody>
       </p:sp>
@@ -2219,12 +2228,20 @@
             <p:ph sz="quarter" idx="17"/>
           </p:nvPr>
         </p:nvSpPr>
-        <p:spPr/>
+        <p:spPr>
+          <a:xfrm>
+            <a:off x="0" y="3657600"/>
+            <a:ext cx="30275213" cy="5043292"/>
+          </a:xfrm>
+        </p:spPr>
         <p:txBody>
           <a:bodyPr/>
           <a:lstStyle/>
           <a:p>
-            <a:endParaRPr lang="de-AT"/>
+            <a:r>
+              <a:rPr lang="en-GB" dirty="0"/>
+              <a:t>Virtuelle Cybersecurity-Testumgebung mit IDS</a:t>
+            </a:r>
           </a:p>
         </p:txBody>
       </p:sp>
@@ -2273,6 +2290,79 @@
           </a:p>
         </p:txBody>
       </p:sp>
+      <p:pic>
+        <p:nvPicPr>
+          <p:cNvPr id="3" name="Bildplatzhalter 2" descr="Ein Bild, das Text, Screenshot, Display, Design enthält.&#10;&#10;KI-generierte Inhalte können fehlerhaft sein.">
+            <a:extLst>
+              <a:ext uri="{FF2B5EF4-FFF2-40B4-BE49-F238E27FC236}">
+                <a16:creationId xmlns:a16="http://schemas.microsoft.com/office/drawing/2014/main" id="{655A65A7-879A-E909-F6C7-C580AEEE115E}"/>
+              </a:ext>
+            </a:extLst>
+          </p:cNvPr>
+          <p:cNvPicPr>
+            <a:picLocks noGrp="1" noChangeAspect="1"/>
+          </p:cNvPicPr>
+          <p:nvPr>
+            <p:ph type="pic" sz="quarter" idx="11"/>
+          </p:nvPr>
+        </p:nvPicPr>
+        <p:blipFill>
+          <a:blip r:embed="rId2">
+            <a:extLst>
+              <a:ext uri="{28A0092B-C50C-407E-A947-70E740481C1C}">
+                <a14:useLocalDpi xmlns:a14="http://schemas.microsoft.com/office/drawing/2010/main" val="0"/>
+              </a:ext>
+            </a:extLst>
+          </a:blip>
+          <a:srcRect l="18401" t="41992" r="17777" b="6516"/>
+          <a:stretch>
+            <a:fillRect/>
+          </a:stretch>
+        </p:blipFill>
+        <p:spPr>
+          <a:xfrm>
+            <a:off x="16741479" y="28403299"/>
+            <a:ext cx="11810322" cy="9720000"/>
+          </a:xfrm>
+          <a:prstGeom prst="rect">
+            <a:avLst/>
+          </a:prstGeom>
+          <a:noFill/>
+        </p:spPr>
+      </p:pic>
+      <p:pic>
+        <p:nvPicPr>
+          <p:cNvPr id="18" name="Bildplatzhalter 17" descr="Ein Bild, das Text, Screenshot, Schrift, Logo enthält.&#10;&#10;KI-generierte Inhalte können fehlerhaft sein.">
+            <a:extLst>
+              <a:ext uri="{FF2B5EF4-FFF2-40B4-BE49-F238E27FC236}">
+                <a16:creationId xmlns:a16="http://schemas.microsoft.com/office/drawing/2014/main" id="{11A5B3F9-B663-6A40-BF45-988125B3E73D}"/>
+              </a:ext>
+            </a:extLst>
+          </p:cNvPr>
+          <p:cNvPicPr>
+            <a:picLocks noGrp="1" noChangeAspect="1"/>
+          </p:cNvPicPr>
+          <p:nvPr>
+            <p:ph type="pic" sz="quarter" idx="10"/>
+          </p:nvPr>
+        </p:nvPicPr>
+        <p:blipFill>
+          <a:blip r:embed="rId3"/>
+          <a:srcRect l="12239" t="17815" r="13581" b="1716"/>
+          <a:stretch>
+            <a:fillRect/>
+          </a:stretch>
+        </p:blipFill>
+        <p:spPr>
+          <a:xfrm>
+            <a:off x="2362200" y="17549916"/>
+            <a:ext cx="9728200" cy="10552904"/>
+          </a:xfrm>
+          <a:prstGeom prst="rect">
+            <a:avLst/>
+          </a:prstGeom>
+        </p:spPr>
+      </p:pic>
     </p:spTree>
     <p:extLst>
       <p:ext uri="{BB962C8B-B14F-4D97-AF65-F5344CB8AC3E}">
@@ -3212,6 +3302,21 @@
 </file>
 
 <file path=customXml/item1.xml><?xml version="1.0" encoding="utf-8"?>
+<p:properties xmlns:p="http://schemas.microsoft.com/office/2006/metadata/properties" xmlns:xsi="http://www.w3.org/2001/XMLSchema-instance" xmlns:pc="http://schemas.microsoft.com/office/infopath/2007/PartnerControls">
+  <documentManagement/>
+</p:properties>
+</file>
+
+<file path=customXml/item2.xml><?xml version="1.0" encoding="utf-8"?>
+<?mso-contentType ?>
+<FormTemplates xmlns="http://schemas.microsoft.com/sharepoint/v3/contenttype/forms">
+  <Display>DocumentLibraryForm</Display>
+  <Edit>DocumentLibraryForm</Edit>
+  <New>DocumentLibraryForm</New>
+</FormTemplates>
+</file>
+
+<file path=customXml/item3.xml><?xml version="1.0" encoding="utf-8"?>
 <ct:contentTypeSchema xmlns:ct="http://schemas.microsoft.com/office/2006/metadata/contentType" xmlns:ma="http://schemas.microsoft.com/office/2006/metadata/properties/metaAttributes" ct:_="" ma:_="" ma:contentTypeName="Document" ma:contentTypeID="0x01010034CB4D94694C6C4497074175C0CB9EC7" ma:contentTypeVersion="9" ma:contentTypeDescription="Create a new document." ma:contentTypeScope="" ma:versionID="978871d5ecab1c5bc96bae753ca5201c">
   <xsd:schema xmlns:xsd="http://www.w3.org/2001/XMLSchema" xmlns:xs="http://www.w3.org/2001/XMLSchema" xmlns:p="http://schemas.microsoft.com/office/2006/metadata/properties" xmlns:ns2="95073dbd-529e-4168-8b89-5095f680e838" targetNamespace="http://schemas.microsoft.com/office/2006/metadata/properties" ma:root="true" ma:fieldsID="683fdc4ed8203e5744d34fe0db2929ab" ns2:_="">
     <xsd:import namespace="95073dbd-529e-4168-8b89-5095f680e838"/>
@@ -3385,29 +3490,37 @@
 </ct:contentTypeSchema>
 </file>
 
-<file path=customXml/item2.xml><?xml version="1.0" encoding="utf-8"?>
-<?mso-contentType ?>
-<FormTemplates xmlns="http://schemas.microsoft.com/sharepoint/v3/contenttype/forms">
-  <Display>DocumentLibraryForm</Display>
-  <Edit>DocumentLibraryForm</Edit>
-  <New>DocumentLibraryForm</New>
-</FormTemplates>
-</file>
-
-<file path=customXml/item3.xml><?xml version="1.0" encoding="utf-8"?>
-<p:properties xmlns:p="http://schemas.microsoft.com/office/2006/metadata/properties" xmlns:xsi="http://www.w3.org/2001/XMLSchema-instance" xmlns:pc="http://schemas.microsoft.com/office/infopath/2007/PartnerControls">
-  <documentManagement/>
-</p:properties>
-</file>
-
 <file path=customXml/itemProps1.xml><?xml version="1.0" encoding="utf-8"?>
-<ds:datastoreItem xmlns:ds="http://schemas.openxmlformats.org/officeDocument/2006/customXml" ds:itemID="{6B8603C9-7727-411E-BD6C-694A8ED01DE9}"/>
+<ds:datastoreItem xmlns:ds="http://schemas.openxmlformats.org/officeDocument/2006/customXml" ds:itemID="{3B2E5DC6-0500-44EE-AED5-81508B4384EA}">
+  <ds:schemaRefs>
+    <ds:schemaRef ds:uri="http://schemas.microsoft.com/office/2006/metadata/properties"/>
+    <ds:schemaRef ds:uri="http://schemas.microsoft.com/office/infopath/2007/PartnerControls"/>
+  </ds:schemaRefs>
+</ds:datastoreItem>
 </file>
 
 <file path=customXml/itemProps2.xml><?xml version="1.0" encoding="utf-8"?>
-<ds:datastoreItem xmlns:ds="http://schemas.openxmlformats.org/officeDocument/2006/customXml" ds:itemID="{33CC1DD1-960A-4156-AAD2-FBE002C9E09E}"/>
+<ds:datastoreItem xmlns:ds="http://schemas.openxmlformats.org/officeDocument/2006/customXml" ds:itemID="{33CC1DD1-960A-4156-AAD2-FBE002C9E09E}">
+  <ds:schemaRefs>
+    <ds:schemaRef ds:uri="http://schemas.microsoft.com/sharepoint/v3/contenttype/forms"/>
+  </ds:schemaRefs>
+</ds:datastoreItem>
 </file>
 
 <file path=customXml/itemProps3.xml><?xml version="1.0" encoding="utf-8"?>
-<ds:datastoreItem xmlns:ds="http://schemas.openxmlformats.org/officeDocument/2006/customXml" ds:itemID="{3B2E5DC6-0500-44EE-AED5-81508B4384EA}"/>
+<ds:datastoreItem xmlns:ds="http://schemas.openxmlformats.org/officeDocument/2006/customXml" ds:itemID="{6B8603C9-7727-411E-BD6C-694A8ED01DE9}">
+  <ds:schemaRefs>
+    <ds:schemaRef ds:uri="http://schemas.microsoft.com/office/2006/metadata/contentType"/>
+    <ds:schemaRef ds:uri="http://schemas.microsoft.com/office/2006/metadata/properties/metaAttributes"/>
+    <ds:schemaRef ds:uri="http://www.w3.org/2001/XMLSchema"/>
+    <ds:schemaRef ds:uri="http://schemas.microsoft.com/office/2006/metadata/properties"/>
+    <ds:schemaRef ds:uri="95073dbd-529e-4168-8b89-5095f680e838"/>
+    <ds:schemaRef ds:uri="http://schemas.microsoft.com/office/2006/documentManagement/types"/>
+    <ds:schemaRef ds:uri="http://schemas.microsoft.com/office/infopath/2007/PartnerControls"/>
+    <ds:schemaRef ds:uri="http://schemas.openxmlformats.org/package/2006/metadata/core-properties"/>
+    <ds:schemaRef ds:uri="http://purl.org/dc/elements/1.1/"/>
+    <ds:schemaRef ds:uri="http://purl.org/dc/terms/"/>
+    <ds:schemaRef ds:uri="http://schemas.microsoft.com/internal/obd"/>
+  </ds:schemaRefs>
+</ds:datastoreItem>
 </file>
</xml_diff>

<commit_message>
Update digital poster template PPTX
Replace HTL-DA_Digitale_PosterVorlage_Infoterminal2.pptx with an updated binary presentation file. This updates the digital poster/template used for the Diplomarbeit infoterminal; no textual diffs are shown due to the binary PPTX format.
</commit_message>
<xml_diff>
--- a/Diplomarbeit/doc/HTL-DA_Digitale_PosterVorlage_Infoterminal2.pptx
+++ b/Diplomarbeit/doc/HTL-DA_Digitale_PosterVorlage_Infoterminal2.pptx
@@ -2095,7 +2095,15 @@
             <a:pPr algn="l"/>
             <a:r>
               <a:rPr lang="de-DE" b="0" dirty="0"/>
-              <a:t>Ziel der Diplomarbeit ist eine sichere digitale Übungsumgebung für den Unterricht. Alle Schülerinnen und Schüler sollen unter denselben technischen Bedingungen arbeiten können – unabhängig von der Leistung des eigenen Laptops. In dieser Umgebung können Cyberangriffe realitätsnah, aber gefahrlos geübt werden. Gleichzeitig soll sichtbar werden, wie Angriffe früh erkannt und nachvollziehbar dargestellt werden können.</a:t>
+              <a:t>Ziel der Diplomarbeit ist die Erstellung und Konfiguration einer sicheren, digitalen </a:t>
+            </a:r>
+            <a:r>
+              <a:rPr lang="de-DE" b="0" dirty="0" err="1"/>
+              <a:t>Cybersecurity</a:t>
+            </a:r>
+            <a:r>
+              <a:rPr lang="de-DE" b="0" dirty="0"/>
+              <a:t>-Range für den Unterricht. In dieser Umgebung können Cyberangriffe realitätsnah, aber gefahrlos geübt werden. Gleichzeitig soll sichtbar werden, wie Angriffe früh erkannt und nachvollziehbar dargestellt werden können.</a:t>
             </a:r>
             <a:endParaRPr lang="de-AT" dirty="0"/>
           </a:p>
@@ -2206,7 +2214,7 @@
             <a:pPr algn="l"/>
             <a:r>
               <a:rPr lang="de-DE" b="0" dirty="0"/>
-              <a:t>Im theoretischen Teil wurde untersucht, wie Angriffe in Computernetzwerken entstehen, welche typischen Angriffsschritte vorkommen und welche Schutzmaßnahmen besonders wirksam sind. Zusätzlich wurden verschiedene Überwachungslösungen zur Angriffserkennung verglichen. Die wichtigste Erkenntnis: Nicht einzelne Tools, sondern das Zusammenspiel aus klaren Sicherheitsregeln, starken Passwörtern, sinnvoll vergebenen Berechtigungen und laufender Überwachung schützt ein Netzwerk nachhaltig. So können viele Sicherheitsvorfälle früh erkannt und begrenzt werden.</a:t>
+              <a:t>Im theoretischen Teil wurde untersucht, wie Angriffe in Computernetzwerken entstehen und welche Schutzmaßnahmen besonders wirksam sind. Zusätzlich wurden verschiedene Lösungen zur Angriffserkennung verglichen. Zentrale Erkenntnis: Nicht einzelne Tools, sondern das Zusammenspiel aus klaren Sicherheitsregeln, starken Passwörtern, sinnvollen Berechtigungen und laufender Überwachung schützt ein Netzwerk nachhaltig. Dadurch können Sicherheitsvorfälle früh erkannt und begrenzt werden.</a:t>
             </a:r>
             <a:endParaRPr lang="de-AT" dirty="0"/>
           </a:p>
@@ -2292,10 +2300,10 @@
       </p:sp>
       <p:pic>
         <p:nvPicPr>
-          <p:cNvPr id="3" name="Bildplatzhalter 2" descr="Ein Bild, das Text, Screenshot, Display, Design enthält.&#10;&#10;KI-generierte Inhalte können fehlerhaft sein.">
+          <p:cNvPr id="7" name="Inhaltsplatzhalter 8" descr="Ein Bild, das Diagramm, Text, Karte enthält.&#10;&#10;KI-generierte Inhalte können fehlerhaft sein.">
             <a:extLst>
               <a:ext uri="{FF2B5EF4-FFF2-40B4-BE49-F238E27FC236}">
-                <a16:creationId xmlns:a16="http://schemas.microsoft.com/office/drawing/2014/main" id="{655A65A7-879A-E909-F6C7-C580AEEE115E}"/>
+                <a16:creationId xmlns:a16="http://schemas.microsoft.com/office/drawing/2014/main" id="{82CC687B-CC70-27A7-D2F8-B4C5C33280ED}"/>
               </a:ext>
             </a:extLst>
           </p:cNvPr>
@@ -2314,20 +2322,19 @@
               </a:ext>
             </a:extLst>
           </a:blip>
-          <a:srcRect l="18401" t="41992" r="17777" b="6516"/>
+          <a:srcRect l="1790" t="-2673" r="5926" b="2673"/>
           <a:stretch>
             <a:fillRect/>
           </a:stretch>
         </p:blipFill>
         <p:spPr>
           <a:xfrm>
-            <a:off x="16741479" y="28403299"/>
-            <a:ext cx="11810322" cy="9720000"/>
+            <a:off x="16225838" y="28703588"/>
+            <a:ext cx="13114337" cy="9121775"/>
           </a:xfrm>
           <a:prstGeom prst="rect">
             <a:avLst/>
           </a:prstGeom>
-          <a:noFill/>
         </p:spPr>
       </p:pic>
       <p:pic>
@@ -2355,7 +2362,7 @@
         </p:blipFill>
         <p:spPr>
           <a:xfrm>
-            <a:off x="2362200" y="17549916"/>
+            <a:off x="3246120" y="17245116"/>
             <a:ext cx="9728200" cy="10552904"/>
           </a:xfrm>
           <a:prstGeom prst="rect">
@@ -3302,18 +3309,18 @@
 </file>
 
 <file path=customXml/item1.xml><?xml version="1.0" encoding="utf-8"?>
-<p:properties xmlns:p="http://schemas.microsoft.com/office/2006/metadata/properties" xmlns:xsi="http://www.w3.org/2001/XMLSchema-instance" xmlns:pc="http://schemas.microsoft.com/office/infopath/2007/PartnerControls">
-  <documentManagement/>
-</p:properties>
-</file>
-
-<file path=customXml/item2.xml><?xml version="1.0" encoding="utf-8"?>
 <?mso-contentType ?>
 <FormTemplates xmlns="http://schemas.microsoft.com/sharepoint/v3/contenttype/forms">
   <Display>DocumentLibraryForm</Display>
   <Edit>DocumentLibraryForm</Edit>
   <New>DocumentLibraryForm</New>
 </FormTemplates>
+</file>
+
+<file path=customXml/item2.xml><?xml version="1.0" encoding="utf-8"?>
+<p:properties xmlns:p="http://schemas.microsoft.com/office/2006/metadata/properties" xmlns:xsi="http://www.w3.org/2001/XMLSchema-instance" xmlns:pc="http://schemas.microsoft.com/office/infopath/2007/PartnerControls">
+  <documentManagement/>
+</p:properties>
 </file>
 
 <file path=customXml/item3.xml><?xml version="1.0" encoding="utf-8"?>
@@ -3491,18 +3498,18 @@
 </file>
 
 <file path=customXml/itemProps1.xml><?xml version="1.0" encoding="utf-8"?>
-<ds:datastoreItem xmlns:ds="http://schemas.openxmlformats.org/officeDocument/2006/customXml" ds:itemID="{3B2E5DC6-0500-44EE-AED5-81508B4384EA}">
+<ds:datastoreItem xmlns:ds="http://schemas.openxmlformats.org/officeDocument/2006/customXml" ds:itemID="{33CC1DD1-960A-4156-AAD2-FBE002C9E09E}">
   <ds:schemaRefs>
-    <ds:schemaRef ds:uri="http://schemas.microsoft.com/office/2006/metadata/properties"/>
-    <ds:schemaRef ds:uri="http://schemas.microsoft.com/office/infopath/2007/PartnerControls"/>
+    <ds:schemaRef ds:uri="http://schemas.microsoft.com/sharepoint/v3/contenttype/forms"/>
   </ds:schemaRefs>
 </ds:datastoreItem>
 </file>
 
 <file path=customXml/itemProps2.xml><?xml version="1.0" encoding="utf-8"?>
-<ds:datastoreItem xmlns:ds="http://schemas.openxmlformats.org/officeDocument/2006/customXml" ds:itemID="{33CC1DD1-960A-4156-AAD2-FBE002C9E09E}">
+<ds:datastoreItem xmlns:ds="http://schemas.openxmlformats.org/officeDocument/2006/customXml" ds:itemID="{3B2E5DC6-0500-44EE-AED5-81508B4384EA}">
   <ds:schemaRefs>
-    <ds:schemaRef ds:uri="http://schemas.microsoft.com/sharepoint/v3/contenttype/forms"/>
+    <ds:schemaRef ds:uri="http://schemas.microsoft.com/office/2006/metadata/properties"/>
+    <ds:schemaRef ds:uri="http://schemas.microsoft.com/office/infopath/2007/PartnerControls"/>
   </ds:schemaRefs>
 </ds:datastoreItem>
 </file>

</xml_diff>